<commit_message>
Regenerate ACME .docx and .pptx with Microsoft brand references removed
</commit_message>
<xml_diff>
--- a/samples/gtm-plan-acme-insight-studio.pptx
+++ b/samples/gtm-plan-acme-insight-studio.pptx
@@ -4505,7 +4505,7 @@
               </a:defRPr>
             </a:pPr>
             <a:r>
-              <a:t>Already where users work: Outlook, Teams, Word</a:t>
+              <a:t>Already where users work: email, chat, docs</a:t>
             </a:r>
           </a:p>
         </p:txBody>
@@ -4649,7 +4649,7 @@
               </a:defRPr>
             </a:pPr>
             <a:r>
-              <a:t>10x faster with Copilot Studio + connectors</a:t>
+              <a:t>10x faster with ACME Studio + connectors</a:t>
             </a:r>
           </a:p>
         </p:txBody>

</xml_diff>

<commit_message>
samples: genericize ACME GTM plan to remove M365 Copilot extensibility terminology
The ACME Insight Studio sample (and the brief/deck generator scripts) still
contained M365 Copilot extensibility-specific phrasing: 'declarative agents',
'API plugins', 'Graph connectors', 'adaptive UI cards', 'conversation extensions',
'200M+ commercial user base', 'ACME Graph API/access', 'Extensibility Opportunity',
and a '15% of Copilot deals' metric. Replace with generic platform-integration
language (AI agents, REST integrations, data connectors, embedded UI components,
in-app chat surfaces, ACME Platform API, 20M+ users, ACME platform deals) so
the sample reads as a generic enterprise AI-platform GTM plan, not a thinly
veiled M365 Copilot extensibility plan. Regenerated the .docx and .pptx from
the updated scripts; PNG previews are stale and will need a re-render on a
Windows + Office host (scripts/render_sample_previews.py).
</commit_message>
<xml_diff>
--- a/samples/gtm-plan-acme-insight-studio.pptx
+++ b/samples/gtm-plan-acme-insight-studio.pptx
@@ -3637,7 +3637,7 @@
               </a:defRPr>
             </a:pPr>
             <a:r>
-              <a:t>The $12B Extensibility Opportunity Is Ours to Capture</a:t>
+              <a:t>The $12B Platform Integration Opportunity Is Ours to Capture</a:t>
             </a:r>
           </a:p>
         </p:txBody>
@@ -3898,7 +3898,7 @@
               </a:defRPr>
             </a:pPr>
             <a:r>
-              <a:t>AI extensibility segment addressable (SAM)</a:t>
+              <a:t>AI platform integration segment addressable (SAM)</a:t>
             </a:r>
           </a:p>
         </p:txBody>
@@ -4123,7 +4123,7 @@
               </a:defRPr>
             </a:pPr>
             <a:r>
-              <a:t>  Competitors 6-12 months behind on enterprise extensibility</a:t>
+              <a:t>  Competitors 6-12 months behind on enterprise platform integration</a:t>
             </a:r>
           </a:p>
         </p:txBody>
@@ -4276,7 +4276,7 @@
               </a:defRPr>
             </a:pPr>
             <a:r>
-              <a:t>Ship AI agents that reach 200M+ users</a:t>
+              <a:t>Ship AI agents that reach 20M+ users</a:t>
             </a:r>
             <a:br/>
             <a:r>
@@ -4433,7 +4433,7 @@
               </a:defRPr>
             </a:pPr>
             <a:r>
-              <a:t>Native ACME Graph, enterprise identity, compliance</a:t>
+              <a:t>Native ACME Platform, enterprise identity, compliance</a:t>
             </a:r>
           </a:p>
         </p:txBody>
@@ -7147,7 +7147,7 @@
               </a:defRPr>
             </a:pPr>
             <a:r>
-              <a:t>of Copilot deals  (Monthly)</a:t>
+              <a:t>of ACME platform deals  (Monthly)</a:t>
             </a:r>
           </a:p>
         </p:txBody>

</xml_diff>